<commit_message>
vault backup: 2026-09-21 09:34:30
</commit_message>
<xml_diff>
--- a/SDLC/Projects/TMP-specimen-sorter-api — Specimen Sorter API/assets/Specimen Sorter API v2.pptx
+++ b/SDLC/Projects/TMP-specimen-sorter-api — Specimen Sorter API/assets/Specimen Sorter API v2.pptx
@@ -3102,7 +3102,7 @@
                       </a:endParaRPr>
                     </a:p>
                   </a:txBody>
-                  <a:tcPr marL="14630400" marR="14630400" marT="0" marB="0" anchor="ctr">
+                  <a:tcPr marL="201168" marR="201168" marT="54864" marB="54864" anchor="ctr">
                     <a:lnL w="0" cap="flat" cmpd="sng" algn="ctr">
                       <a:noFill/>
                     </a:lnL>
@@ -3152,7 +3152,7 @@
                       </a:endParaRPr>
                     </a:p>
                   </a:txBody>
-                  <a:tcPr marL="14630400" marR="14630400" marT="0" marB="0" anchor="ctr">
+                  <a:tcPr marL="201168" marR="201168" marT="54864" marB="54864" anchor="ctr">
                     <a:lnL w="0" cap="flat" cmpd="sng" algn="ctr">
                       <a:noFill/>
                     </a:lnL>
@@ -3202,7 +3202,7 @@
                       </a:endParaRPr>
                     </a:p>
                   </a:txBody>
-                  <a:tcPr marL="14630400" marR="14630400" marT="0" marB="0" anchor="ctr">
+                  <a:tcPr marL="201168" marR="201168" marT="54864" marB="54864" anchor="ctr">
                     <a:lnL w="0" cap="flat" cmpd="sng" algn="ctr">
                       <a:noFill/>
                     </a:lnL>
@@ -3252,7 +3252,7 @@
                       </a:endParaRPr>
                     </a:p>
                   </a:txBody>
-                  <a:tcPr marL="14630400" marR="14630400" marT="0" marB="0" anchor="ctr">
+                  <a:tcPr marL="201168" marR="201168" marT="54864" marB="54864" anchor="ctr">
                     <a:lnL w="0" cap="flat" cmpd="sng" algn="ctr">
                       <a:noFill/>
                     </a:lnL>
@@ -3304,7 +3304,7 @@
                       </a:endParaRPr>
                     </a:p>
                   </a:txBody>
-                  <a:tcPr marL="14630400" marR="14630400" marT="0" marB="0" anchor="ctr">
+                  <a:tcPr marL="201168" marR="201168" marT="54864" marB="54864" anchor="ctr">
                     <a:lnL w="0" cap="flat" cmpd="sng" algn="ctr">
                       <a:noFill/>
                     </a:lnL>
@@ -3354,7 +3354,7 @@
                       </a:endParaRPr>
                     </a:p>
                   </a:txBody>
-                  <a:tcPr marL="14630400" marR="14630400" marT="0" marB="0" anchor="ctr">
+                  <a:tcPr marL="201168" marR="201168" marT="54864" marB="54864" anchor="ctr">
                     <a:lnL w="0" cap="flat" cmpd="sng" algn="ctr">
                       <a:noFill/>
                     </a:lnL>
@@ -3404,7 +3404,7 @@
                       </a:endParaRPr>
                     </a:p>
                   </a:txBody>
-                  <a:tcPr marL="14630400" marR="14630400" marT="0" marB="0" anchor="ctr">
+                  <a:tcPr marL="201168" marR="201168" marT="54864" marB="54864" anchor="ctr">
                     <a:lnL w="0" cap="flat" cmpd="sng" algn="ctr">
                       <a:noFill/>
                     </a:lnL>
@@ -3454,7 +3454,7 @@
                       </a:endParaRPr>
                     </a:p>
                   </a:txBody>
-                  <a:tcPr marL="14630400" marR="14630400" marT="0" marB="0" anchor="ctr">
+                  <a:tcPr marL="201168" marR="201168" marT="54864" marB="54864" anchor="ctr">
                     <a:lnL w="0" cap="flat" cmpd="sng" algn="ctr">
                       <a:noFill/>
                     </a:lnL>
@@ -3506,7 +3506,7 @@
                       </a:endParaRPr>
                     </a:p>
                   </a:txBody>
-                  <a:tcPr marL="14630400" marR="14630400" marT="0" marB="0" anchor="ctr">
+                  <a:tcPr marL="201168" marR="201168" marT="54864" marB="54864" anchor="ctr">
                     <a:lnL w="0" cap="flat" cmpd="sng" algn="ctr">
                       <a:noFill/>
                     </a:lnL>
@@ -3556,7 +3556,7 @@
                       </a:endParaRPr>
                     </a:p>
                   </a:txBody>
-                  <a:tcPr marL="14630400" marR="14630400" marT="0" marB="0" anchor="ctr">
+                  <a:tcPr marL="201168" marR="201168" marT="54864" marB="54864" anchor="ctr">
                     <a:lnL w="0" cap="flat" cmpd="sng" algn="ctr">
                       <a:noFill/>
                     </a:lnL>
@@ -3606,7 +3606,7 @@
                       </a:endParaRPr>
                     </a:p>
                   </a:txBody>
-                  <a:tcPr marL="14630400" marR="14630400" marT="0" marB="0" anchor="ctr">
+                  <a:tcPr marL="201168" marR="201168" marT="54864" marB="54864" anchor="ctr">
                     <a:lnL w="0" cap="flat" cmpd="sng" algn="ctr">
                       <a:noFill/>
                     </a:lnL>
@@ -3656,7 +3656,7 @@
                       </a:endParaRPr>
                     </a:p>
                   </a:txBody>
-                  <a:tcPr marL="14630400" marR="14630400" marT="0" marB="0" anchor="ctr">
+                  <a:tcPr marL="201168" marR="201168" marT="54864" marB="54864" anchor="ctr">
                     <a:lnL w="0" cap="flat" cmpd="sng" algn="ctr">
                       <a:noFill/>
                     </a:lnL>
@@ -3708,7 +3708,7 @@
                       </a:endParaRPr>
                     </a:p>
                   </a:txBody>
-                  <a:tcPr marL="14630400" marR="14630400" marT="0" marB="0" anchor="ctr">
+                  <a:tcPr marL="201168" marR="201168" marT="54864" marB="54864" anchor="ctr">
                     <a:lnL w="0" cap="flat" cmpd="sng" algn="ctr">
                       <a:noFill/>
                     </a:lnL>
@@ -3758,7 +3758,7 @@
                       </a:endParaRPr>
                     </a:p>
                   </a:txBody>
-                  <a:tcPr marL="14630400" marR="14630400" marT="0" marB="0" anchor="ctr">
+                  <a:tcPr marL="201168" marR="201168" marT="54864" marB="54864" anchor="ctr">
                     <a:lnL w="0" cap="flat" cmpd="sng" algn="ctr">
                       <a:noFill/>
                     </a:lnL>
@@ -3808,7 +3808,7 @@
                       </a:endParaRPr>
                     </a:p>
                   </a:txBody>
-                  <a:tcPr marL="14630400" marR="14630400" marT="0" marB="0" anchor="ctr">
+                  <a:tcPr marL="201168" marR="201168" marT="54864" marB="54864" anchor="ctr">
                     <a:lnL w="0" cap="flat" cmpd="sng" algn="ctr">
                       <a:noFill/>
                     </a:lnL>
@@ -3858,7 +3858,7 @@
                       </a:endParaRPr>
                     </a:p>
                   </a:txBody>
-                  <a:tcPr marL="14630400" marR="14630400" marT="0" marB="0" anchor="ctr">
+                  <a:tcPr marL="201168" marR="201168" marT="54864" marB="54864" anchor="ctr">
                     <a:lnL w="0" cap="flat" cmpd="sng" algn="ctr">
                       <a:noFill/>
                     </a:lnL>
@@ -3910,7 +3910,7 @@
                       </a:endParaRPr>
                     </a:p>
                   </a:txBody>
-                  <a:tcPr marL="14630400" marR="14630400" marT="0" marB="0" anchor="ctr">
+                  <a:tcPr marL="201168" marR="201168" marT="54864" marB="54864" anchor="ctr">
                     <a:lnL w="0" cap="flat" cmpd="sng" algn="ctr">
                       <a:noFill/>
                     </a:lnL>
@@ -3954,7 +3954,7 @@
                       </a:endParaRPr>
                     </a:p>
                   </a:txBody>
-                  <a:tcPr marL="14630400" marR="14630400" marT="0" marB="0" anchor="ctr">
+                  <a:tcPr marL="201168" marR="201168" marT="54864" marB="54864" anchor="ctr">
                     <a:lnL w="0" cap="flat" cmpd="sng" algn="ctr">
                       <a:noFill/>
                     </a:lnL>
@@ -3998,7 +3998,7 @@
                       </a:endParaRPr>
                     </a:p>
                   </a:txBody>
-                  <a:tcPr marL="14630400" marR="14630400" marT="0" marB="0" anchor="ctr">
+                  <a:tcPr marL="201168" marR="201168" marT="54864" marB="54864" anchor="ctr">
                     <a:lnL w="0" cap="flat" cmpd="sng" algn="ctr">
                       <a:noFill/>
                     </a:lnL>
@@ -4042,7 +4042,7 @@
                       </a:endParaRPr>
                     </a:p>
                   </a:txBody>
-                  <a:tcPr marL="14630400" marR="14630400" marT="0" marB="0" anchor="ctr">
+                  <a:tcPr marL="201168" marR="201168" marT="54864" marB="54864" anchor="ctr">
                     <a:lnL w="0" cap="flat" cmpd="sng" algn="ctr">
                       <a:noFill/>
                     </a:lnL>
@@ -4802,7 +4802,7 @@
       </p:sp>
       <p:pic>
         <p:nvPicPr>
-          <p:cNvPr id="5" name="Image 0" descr="/Users/dragonchong/Application/Obsidian/HA-Notes/LIS/skills/design-review-pptx/assets/icons/png/success/cloud-arrow-up.png">    </p:cNvPr>
+          <p:cNvPr id="5" name="Image 0" descr="D:\Github\HA-Notes\LIS\skills\design-review-pptx\assets\icons\png\success\cloud-arrow-up.png">    </p:cNvPr>
           <p:cNvPicPr>
             <a:picLocks noChangeAspect="1"/>
           </p:cNvPicPr>
@@ -5417,7 +5417,7 @@
       </p:sp>
       <p:pic>
         <p:nvPicPr>
-          <p:cNvPr id="20" name="Image 1" descr="/Users/dragonchong/Application/Obsidian/HA-Notes/LIS/skills/design-review-pptx/assets/icons/png/danger/rotate-left.png">    </p:cNvPr>
+          <p:cNvPr id="20" name="Image 1" descr="D:\Github\HA-Notes\LIS\skills\design-review-pptx\assets\icons\png\danger\rotate-left.png">    </p:cNvPr>
           <p:cNvPicPr>
             <a:picLocks noChangeAspect="1"/>
           </p:cNvPicPr>
@@ -6639,7 +6639,7 @@
       </p:sp>
       <p:pic>
         <p:nvPicPr>
-          <p:cNvPr id="3" name="Image 0" descr="/Users/dragonchong/Application/Obsidian/HA-Notes/LIS/skills/design-review-pptx/assets/icons/png/onDark/rocket.png">    </p:cNvPr>
+          <p:cNvPr id="3" name="Image 0" descr="D:\Github\HA-Notes\LIS\skills\design-review-pptx\assets\icons\png\onDark\rocket.png">    </p:cNvPr>
           <p:cNvPicPr>
             <a:picLocks noChangeAspect="1"/>
           </p:cNvPicPr>
@@ -9079,7 +9079,7 @@
                       </a:endParaRPr>
                     </a:p>
                   </a:txBody>
-                  <a:tcPr marL="14630400" marR="14630400" marT="0" marB="0" anchor="ctr">
+                  <a:tcPr marL="201168" marR="201168" marT="54864" marB="54864" anchor="ctr">
                     <a:lnL w="0" cap="flat" cmpd="sng" algn="ctr">
                       <a:noFill/>
                     </a:lnL>
@@ -9129,7 +9129,7 @@
                       </a:endParaRPr>
                     </a:p>
                   </a:txBody>
-                  <a:tcPr marL="14630400" marR="14630400" marT="0" marB="0" anchor="ctr">
+                  <a:tcPr marL="201168" marR="201168" marT="54864" marB="54864" anchor="ctr">
                     <a:lnL w="0" cap="flat" cmpd="sng" algn="ctr">
                       <a:noFill/>
                     </a:lnL>
@@ -9179,7 +9179,7 @@
                       </a:endParaRPr>
                     </a:p>
                   </a:txBody>
-                  <a:tcPr marL="14630400" marR="14630400" marT="0" marB="0" anchor="ctr">
+                  <a:tcPr marL="201168" marR="201168" marT="54864" marB="54864" anchor="ctr">
                     <a:lnL w="0" cap="flat" cmpd="sng" algn="ctr">
                       <a:noFill/>
                     </a:lnL>
@@ -9229,7 +9229,7 @@
                       </a:endParaRPr>
                     </a:p>
                   </a:txBody>
-                  <a:tcPr marL="14630400" marR="14630400" marT="0" marB="0" anchor="ctr">
+                  <a:tcPr marL="201168" marR="201168" marT="54864" marB="54864" anchor="ctr">
                     <a:lnL w="0" cap="flat" cmpd="sng" algn="ctr">
                       <a:noFill/>
                     </a:lnL>
@@ -9281,7 +9281,7 @@
                       </a:endParaRPr>
                     </a:p>
                   </a:txBody>
-                  <a:tcPr marL="14630400" marR="14630400" marT="0" marB="0" anchor="ctr">
+                  <a:tcPr marL="201168" marR="201168" marT="54864" marB="54864" anchor="ctr">
                     <a:lnL w="0" cap="flat" cmpd="sng" algn="ctr">
                       <a:noFill/>
                     </a:lnL>
@@ -9331,7 +9331,7 @@
                       </a:endParaRPr>
                     </a:p>
                   </a:txBody>
-                  <a:tcPr marL="14630400" marR="14630400" marT="0" marB="0" anchor="ctr">
+                  <a:tcPr marL="201168" marR="201168" marT="54864" marB="54864" anchor="ctr">
                     <a:lnL w="0" cap="flat" cmpd="sng" algn="ctr">
                       <a:noFill/>
                     </a:lnL>
@@ -9381,7 +9381,7 @@
                       </a:endParaRPr>
                     </a:p>
                   </a:txBody>
-                  <a:tcPr marL="14630400" marR="14630400" marT="0" marB="0" anchor="ctr">
+                  <a:tcPr marL="201168" marR="201168" marT="54864" marB="54864" anchor="ctr">
                     <a:lnL w="0" cap="flat" cmpd="sng" algn="ctr">
                       <a:noFill/>
                     </a:lnL>
@@ -9431,7 +9431,7 @@
                       </a:endParaRPr>
                     </a:p>
                   </a:txBody>
-                  <a:tcPr marL="14630400" marR="14630400" marT="0" marB="0" anchor="ctr">
+                  <a:tcPr marL="201168" marR="201168" marT="54864" marB="54864" anchor="ctr">
                     <a:lnL w="0" cap="flat" cmpd="sng" algn="ctr">
                       <a:noFill/>
                     </a:lnL>
@@ -9483,7 +9483,7 @@
                       </a:endParaRPr>
                     </a:p>
                   </a:txBody>
-                  <a:tcPr marL="14630400" marR="14630400" marT="0" marB="0" anchor="ctr">
+                  <a:tcPr marL="201168" marR="201168" marT="54864" marB="54864" anchor="ctr">
                     <a:lnL w="0" cap="flat" cmpd="sng" algn="ctr">
                       <a:noFill/>
                     </a:lnL>
@@ -9533,7 +9533,7 @@
                       </a:endParaRPr>
                     </a:p>
                   </a:txBody>
-                  <a:tcPr marL="14630400" marR="14630400" marT="0" marB="0" anchor="ctr">
+                  <a:tcPr marL="201168" marR="201168" marT="54864" marB="54864" anchor="ctr">
                     <a:lnL w="0" cap="flat" cmpd="sng" algn="ctr">
                       <a:noFill/>
                     </a:lnL>
@@ -9583,7 +9583,7 @@
                       </a:endParaRPr>
                     </a:p>
                   </a:txBody>
-                  <a:tcPr marL="14630400" marR="14630400" marT="0" marB="0" anchor="ctr">
+                  <a:tcPr marL="201168" marR="201168" marT="54864" marB="54864" anchor="ctr">
                     <a:lnL w="0" cap="flat" cmpd="sng" algn="ctr">
                       <a:noFill/>
                     </a:lnL>
@@ -9633,7 +9633,7 @@
                       </a:endParaRPr>
                     </a:p>
                   </a:txBody>
-                  <a:tcPr marL="14630400" marR="14630400" marT="0" marB="0" anchor="ctr">
+                  <a:tcPr marL="201168" marR="201168" marT="54864" marB="54864" anchor="ctr">
                     <a:lnL w="0" cap="flat" cmpd="sng" algn="ctr">
                       <a:noFill/>
                     </a:lnL>
@@ -9685,7 +9685,7 @@
                       </a:endParaRPr>
                     </a:p>
                   </a:txBody>
-                  <a:tcPr marL="14630400" marR="14630400" marT="0" marB="0" anchor="ctr">
+                  <a:tcPr marL="201168" marR="201168" marT="54864" marB="54864" anchor="ctr">
                     <a:lnL w="0" cap="flat" cmpd="sng" algn="ctr">
                       <a:noFill/>
                     </a:lnL>
@@ -9735,7 +9735,7 @@
                       </a:endParaRPr>
                     </a:p>
                   </a:txBody>
-                  <a:tcPr marL="14630400" marR="14630400" marT="0" marB="0" anchor="ctr">
+                  <a:tcPr marL="201168" marR="201168" marT="54864" marB="54864" anchor="ctr">
                     <a:lnL w="0" cap="flat" cmpd="sng" algn="ctr">
                       <a:noFill/>
                     </a:lnL>
@@ -9785,7 +9785,7 @@
                       </a:endParaRPr>
                     </a:p>
                   </a:txBody>
-                  <a:tcPr marL="14630400" marR="14630400" marT="0" marB="0" anchor="ctr">
+                  <a:tcPr marL="201168" marR="201168" marT="54864" marB="54864" anchor="ctr">
                     <a:lnL w="0" cap="flat" cmpd="sng" algn="ctr">
                       <a:noFill/>
                     </a:lnL>
@@ -9835,7 +9835,7 @@
                       </a:endParaRPr>
                     </a:p>
                   </a:txBody>
-                  <a:tcPr marL="14630400" marR="14630400" marT="0" marB="0" anchor="ctr">
+                  <a:tcPr marL="201168" marR="201168" marT="54864" marB="54864" anchor="ctr">
                     <a:lnL w="0" cap="flat" cmpd="sng" algn="ctr">
                       <a:noFill/>
                     </a:lnL>
@@ -9887,7 +9887,7 @@
                       </a:endParaRPr>
                     </a:p>
                   </a:txBody>
-                  <a:tcPr marL="14630400" marR="14630400" marT="0" marB="0" anchor="ctr">
+                  <a:tcPr marL="201168" marR="201168" marT="54864" marB="54864" anchor="ctr">
                     <a:lnL w="0" cap="flat" cmpd="sng" algn="ctr">
                       <a:noFill/>
                     </a:lnL>
@@ -9937,7 +9937,7 @@
                       </a:endParaRPr>
                     </a:p>
                   </a:txBody>
-                  <a:tcPr marL="14630400" marR="14630400" marT="0" marB="0" anchor="ctr">
+                  <a:tcPr marL="201168" marR="201168" marT="54864" marB="54864" anchor="ctr">
                     <a:lnL w="0" cap="flat" cmpd="sng" algn="ctr">
                       <a:noFill/>
                     </a:lnL>
@@ -9987,7 +9987,7 @@
                       </a:endParaRPr>
                     </a:p>
                   </a:txBody>
-                  <a:tcPr marL="14630400" marR="14630400" marT="0" marB="0" anchor="ctr">
+                  <a:tcPr marL="201168" marR="201168" marT="54864" marB="54864" anchor="ctr">
                     <a:lnL w="0" cap="flat" cmpd="sng" algn="ctr">
                       <a:noFill/>
                     </a:lnL>
@@ -10037,7 +10037,7 @@
                       </a:endParaRPr>
                     </a:p>
                   </a:txBody>
-                  <a:tcPr marL="14630400" marR="14630400" marT="0" marB="0" anchor="ctr">
+                  <a:tcPr marL="201168" marR="201168" marT="54864" marB="54864" anchor="ctr">
                     <a:lnL w="0" cap="flat" cmpd="sng" algn="ctr">
                       <a:noFill/>
                     </a:lnL>
@@ -10089,7 +10089,7 @@
                       </a:endParaRPr>
                     </a:p>
                   </a:txBody>
-                  <a:tcPr marL="14630400" marR="14630400" marT="0" marB="0" anchor="ctr">
+                  <a:tcPr marL="201168" marR="201168" marT="54864" marB="54864" anchor="ctr">
                     <a:lnL w="0" cap="flat" cmpd="sng" algn="ctr">
                       <a:noFill/>
                     </a:lnL>
@@ -10139,7 +10139,7 @@
                       </a:endParaRPr>
                     </a:p>
                   </a:txBody>
-                  <a:tcPr marL="14630400" marR="14630400" marT="0" marB="0" anchor="ctr">
+                  <a:tcPr marL="201168" marR="201168" marT="54864" marB="54864" anchor="ctr">
                     <a:lnL w="0" cap="flat" cmpd="sng" algn="ctr">
                       <a:noFill/>
                     </a:lnL>
@@ -10189,7 +10189,7 @@
                       </a:endParaRPr>
                     </a:p>
                   </a:txBody>
-                  <a:tcPr marL="14630400" marR="14630400" marT="0" marB="0" anchor="ctr">
+                  <a:tcPr marL="201168" marR="201168" marT="54864" marB="54864" anchor="ctr">
                     <a:lnL w="0" cap="flat" cmpd="sng" algn="ctr">
                       <a:noFill/>
                     </a:lnL>
@@ -10239,7 +10239,7 @@
                       </a:endParaRPr>
                     </a:p>
                   </a:txBody>
-                  <a:tcPr marL="14630400" marR="14630400" marT="0" marB="0" anchor="ctr">
+                  <a:tcPr marL="201168" marR="201168" marT="54864" marB="54864" anchor="ctr">
                     <a:lnL w="0" cap="flat" cmpd="sng" algn="ctr">
                       <a:noFill/>
                     </a:lnL>
@@ -10291,7 +10291,7 @@
                       </a:endParaRPr>
                     </a:p>
                   </a:txBody>
-                  <a:tcPr marL="14630400" marR="14630400" marT="0" marB="0" anchor="ctr">
+                  <a:tcPr marL="201168" marR="201168" marT="54864" marB="54864" anchor="ctr">
                     <a:lnL w="0" cap="flat" cmpd="sng" algn="ctr">
                       <a:noFill/>
                     </a:lnL>
@@ -10335,7 +10335,7 @@
                       </a:endParaRPr>
                     </a:p>
                   </a:txBody>
-                  <a:tcPr marL="14630400" marR="14630400" marT="0" marB="0" anchor="ctr">
+                  <a:tcPr marL="201168" marR="201168" marT="54864" marB="54864" anchor="ctr">
                     <a:lnL w="0" cap="flat" cmpd="sng" algn="ctr">
                       <a:noFill/>
                     </a:lnL>
@@ -10379,7 +10379,7 @@
                       </a:endParaRPr>
                     </a:p>
                   </a:txBody>
-                  <a:tcPr marL="14630400" marR="14630400" marT="0" marB="0" anchor="ctr">
+                  <a:tcPr marL="201168" marR="201168" marT="54864" marB="54864" anchor="ctr">
                     <a:lnL w="0" cap="flat" cmpd="sng" algn="ctr">
                       <a:noFill/>
                     </a:lnL>
@@ -10423,7 +10423,7 @@
                       </a:endParaRPr>
                     </a:p>
                   </a:txBody>
-                  <a:tcPr marL="14630400" marR="14630400" marT="0" marB="0" anchor="ctr">
+                  <a:tcPr marL="201168" marR="201168" marT="54864" marB="54864" anchor="ctr">
                     <a:lnL w="0" cap="flat" cmpd="sng" algn="ctr">
                       <a:noFill/>
                     </a:lnL>
@@ -10614,7 +10614,7 @@
       </p:sp>
       <p:pic>
         <p:nvPicPr>
-          <p:cNvPr id="5" name="Image 0" descr="/Users/dragonchong/Application/Obsidian/HA-Notes/LIS/skills/design-review-pptx/assets/icons/png/accent/code.png">    </p:cNvPr>
+          <p:cNvPr id="5" name="Image 0" descr="D:\Github\HA-Notes\LIS\skills\design-review-pptx\assets\icons\png\accent\code.png">    </p:cNvPr>
           <p:cNvPicPr>
             <a:picLocks noChangeAspect="1"/>
           </p:cNvPicPr>
@@ -10749,7 +10749,7 @@
       </p:sp>
       <p:pic>
         <p:nvPicPr>
-          <p:cNvPr id="9" name="Image 1" descr="/Users/dragonchong/Application/Obsidian/HA-Notes/LIS/skills/design-review-pptx/assets/icons/png/accent/layer-group.png">    </p:cNvPr>
+          <p:cNvPr id="9" name="Image 1" descr="D:\Github\HA-Notes\LIS\skills\design-review-pptx\assets\icons\png\accent\layer-group.png">    </p:cNvPr>
           <p:cNvPicPr>
             <a:picLocks noChangeAspect="1"/>
           </p:cNvPicPr>
@@ -10884,7 +10884,7 @@
       </p:sp>
       <p:pic>
         <p:nvPicPr>
-          <p:cNvPr id="13" name="Image 2" descr="/Users/dragonchong/Application/Obsidian/HA-Notes/LIS/skills/design-review-pptx/assets/icons/png/accent/table.png">    </p:cNvPr>
+          <p:cNvPr id="13" name="Image 2" descr="D:\Github\HA-Notes\LIS\skills\design-review-pptx\assets\icons\png\accent\table.png">    </p:cNvPr>
           <p:cNvPicPr>
             <a:picLocks noChangeAspect="1"/>
           </p:cNvPicPr>
@@ -11019,7 +11019,7 @@
       </p:sp>
       <p:pic>
         <p:nvPicPr>
-          <p:cNvPr id="17" name="Image 3" descr="/Users/dragonchong/Application/Obsidian/HA-Notes/LIS/skills/design-review-pptx/assets/icons/png/accent/clipboard-check.png">    </p:cNvPr>
+          <p:cNvPr id="17" name="Image 3" descr="D:\Github\HA-Notes\LIS\skills\design-review-pptx\assets\icons\png\accent\clipboard-check.png">    </p:cNvPr>
           <p:cNvPicPr>
             <a:picLocks noChangeAspect="1"/>
           </p:cNvPicPr>
@@ -13368,7 +13368,7 @@
       </p:sp>
       <p:pic>
         <p:nvPicPr>
-          <p:cNvPr id="9" name="Image 0" descr="/Users/dragonchong/Application/Obsidian/HA-Notes/LIS/skills/design-review-pptx/assets/icons/png/accent/key.png">    </p:cNvPr>
+          <p:cNvPr id="9" name="Image 0" descr="D:\Github\HA-Notes\LIS\skills\design-review-pptx\assets\icons\png\accent\key.png">    </p:cNvPr>
           <p:cNvPicPr>
             <a:picLocks noChangeAspect="1"/>
           </p:cNvPicPr>
@@ -13503,7 +13503,7 @@
       </p:sp>
       <p:pic>
         <p:nvPicPr>
-          <p:cNvPr id="13" name="Image 1" descr="/Users/dragonchong/Application/Obsidian/HA-Notes/LIS/skills/design-review-pptx/assets/icons/png/accent/server.png">    </p:cNvPr>
+          <p:cNvPr id="13" name="Image 1" descr="D:\Github\HA-Notes\LIS\skills\design-review-pptx\assets\icons\png\accent\server.png">    </p:cNvPr>
           <p:cNvPicPr>
             <a:picLocks noChangeAspect="1"/>
           </p:cNvPicPr>
@@ -13638,7 +13638,7 @@
       </p:sp>
       <p:pic>
         <p:nvPicPr>
-          <p:cNvPr id="17" name="Image 2" descr="/Users/dragonchong/Application/Obsidian/HA-Notes/LIS/skills/design-review-pptx/assets/icons/png/accent/triangle-exclamation.png">    </p:cNvPr>
+          <p:cNvPr id="17" name="Image 2" descr="D:\Github\HA-Notes\LIS\skills\design-review-pptx\assets\icons\png\accent\triangle-exclamation.png">    </p:cNvPr>
           <p:cNvPicPr>
             <a:picLocks noChangeAspect="1"/>
           </p:cNvPicPr>
@@ -14604,7 +14604,7 @@
                       </a:endParaRPr>
                     </a:p>
                   </a:txBody>
-                  <a:tcPr marL="14630400" marR="14630400" marT="0" marB="0" anchor="ctr">
+                  <a:tcPr marL="201168" marR="201168" marT="54864" marB="54864" anchor="ctr">
                     <a:lnL w="0" cap="flat" cmpd="sng" algn="ctr">
                       <a:noFill/>
                     </a:lnL>
@@ -14654,7 +14654,7 @@
                       </a:endParaRPr>
                     </a:p>
                   </a:txBody>
-                  <a:tcPr marL="14630400" marR="14630400" marT="0" marB="0" anchor="ctr">
+                  <a:tcPr marL="201168" marR="201168" marT="54864" marB="54864" anchor="ctr">
                     <a:lnL w="0" cap="flat" cmpd="sng" algn="ctr">
                       <a:noFill/>
                     </a:lnL>
@@ -14704,7 +14704,7 @@
                       </a:endParaRPr>
                     </a:p>
                   </a:txBody>
-                  <a:tcPr marL="14630400" marR="14630400" marT="0" marB="0" anchor="ctr">
+                  <a:tcPr marL="201168" marR="201168" marT="54864" marB="54864" anchor="ctr">
                     <a:lnL w="0" cap="flat" cmpd="sng" algn="ctr">
                       <a:noFill/>
                     </a:lnL>
@@ -14756,7 +14756,7 @@
                       </a:endParaRPr>
                     </a:p>
                   </a:txBody>
-                  <a:tcPr marL="14630400" marR="14630400" marT="0" marB="0" anchor="ctr">
+                  <a:tcPr marL="201168" marR="201168" marT="54864" marB="54864" anchor="ctr">
                     <a:lnL w="0" cap="flat" cmpd="sng" algn="ctr">
                       <a:noFill/>
                     </a:lnL>
@@ -14806,7 +14806,7 @@
                       </a:endParaRPr>
                     </a:p>
                   </a:txBody>
-                  <a:tcPr marL="14630400" marR="14630400" marT="0" marB="0" anchor="ctr">
+                  <a:tcPr marL="201168" marR="201168" marT="54864" marB="54864" anchor="ctr">
                     <a:lnL w="0" cap="flat" cmpd="sng" algn="ctr">
                       <a:noFill/>
                     </a:lnL>
@@ -14856,7 +14856,7 @@
                       </a:endParaRPr>
                     </a:p>
                   </a:txBody>
-                  <a:tcPr marL="14630400" marR="14630400" marT="0" marB="0" anchor="ctr">
+                  <a:tcPr marL="201168" marR="201168" marT="54864" marB="54864" anchor="ctr">
                     <a:lnL w="0" cap="flat" cmpd="sng" algn="ctr">
                       <a:noFill/>
                     </a:lnL>
@@ -14908,7 +14908,7 @@
                       </a:endParaRPr>
                     </a:p>
                   </a:txBody>
-                  <a:tcPr marL="14630400" marR="14630400" marT="0" marB="0" anchor="ctr">
+                  <a:tcPr marL="201168" marR="201168" marT="54864" marB="54864" anchor="ctr">
                     <a:lnL w="0" cap="flat" cmpd="sng" algn="ctr">
                       <a:noFill/>
                     </a:lnL>
@@ -14958,7 +14958,7 @@
                       </a:endParaRPr>
                     </a:p>
                   </a:txBody>
-                  <a:tcPr marL="14630400" marR="14630400" marT="0" marB="0" anchor="ctr">
+                  <a:tcPr marL="201168" marR="201168" marT="54864" marB="54864" anchor="ctr">
                     <a:lnL w="0" cap="flat" cmpd="sng" algn="ctr">
                       <a:noFill/>
                     </a:lnL>
@@ -15008,7 +15008,7 @@
                       </a:endParaRPr>
                     </a:p>
                   </a:txBody>
-                  <a:tcPr marL="14630400" marR="14630400" marT="0" marB="0" anchor="ctr">
+                  <a:tcPr marL="201168" marR="201168" marT="54864" marB="54864" anchor="ctr">
                     <a:lnL w="0" cap="flat" cmpd="sng" algn="ctr">
                       <a:noFill/>
                     </a:lnL>
@@ -15060,7 +15060,7 @@
                       </a:endParaRPr>
                     </a:p>
                   </a:txBody>
-                  <a:tcPr marL="14630400" marR="14630400" marT="0" marB="0" anchor="ctr">
+                  <a:tcPr marL="201168" marR="201168" marT="54864" marB="54864" anchor="ctr">
                     <a:lnL w="0" cap="flat" cmpd="sng" algn="ctr">
                       <a:noFill/>
                     </a:lnL>
@@ -15110,7 +15110,7 @@
                       </a:endParaRPr>
                     </a:p>
                   </a:txBody>
-                  <a:tcPr marL="14630400" marR="14630400" marT="0" marB="0" anchor="ctr">
+                  <a:tcPr marL="201168" marR="201168" marT="54864" marB="54864" anchor="ctr">
                     <a:lnL w="0" cap="flat" cmpd="sng" algn="ctr">
                       <a:noFill/>
                     </a:lnL>
@@ -15160,7 +15160,7 @@
                       </a:endParaRPr>
                     </a:p>
                   </a:txBody>
-                  <a:tcPr marL="14630400" marR="14630400" marT="0" marB="0" anchor="ctr">
+                  <a:tcPr marL="201168" marR="201168" marT="54864" marB="54864" anchor="ctr">
                     <a:lnL w="0" cap="flat" cmpd="sng" algn="ctr">
                       <a:noFill/>
                     </a:lnL>
@@ -15212,7 +15212,7 @@
                       </a:endParaRPr>
                     </a:p>
                   </a:txBody>
-                  <a:tcPr marL="14630400" marR="14630400" marT="0" marB="0" anchor="ctr">
+                  <a:tcPr marL="201168" marR="201168" marT="54864" marB="54864" anchor="ctr">
                     <a:lnL w="0" cap="flat" cmpd="sng" algn="ctr">
                       <a:noFill/>
                     </a:lnL>
@@ -15262,7 +15262,7 @@
                       </a:endParaRPr>
                     </a:p>
                   </a:txBody>
-                  <a:tcPr marL="14630400" marR="14630400" marT="0" marB="0" anchor="ctr">
+                  <a:tcPr marL="201168" marR="201168" marT="54864" marB="54864" anchor="ctr">
                     <a:lnL w="0" cap="flat" cmpd="sng" algn="ctr">
                       <a:noFill/>
                     </a:lnL>
@@ -15312,7 +15312,7 @@
                       </a:endParaRPr>
                     </a:p>
                   </a:txBody>
-                  <a:tcPr marL="14630400" marR="14630400" marT="0" marB="0" anchor="ctr">
+                  <a:tcPr marL="201168" marR="201168" marT="54864" marB="54864" anchor="ctr">
                     <a:lnL w="0" cap="flat" cmpd="sng" algn="ctr">
                       <a:noFill/>
                     </a:lnL>
@@ -15364,7 +15364,7 @@
                       </a:endParaRPr>
                     </a:p>
                   </a:txBody>
-                  <a:tcPr marL="14630400" marR="14630400" marT="0" marB="0" anchor="ctr">
+                  <a:tcPr marL="201168" marR="201168" marT="54864" marB="54864" anchor="ctr">
                     <a:lnL w="0" cap="flat" cmpd="sng" algn="ctr">
                       <a:noFill/>
                     </a:lnL>
@@ -15414,7 +15414,7 @@
                       </a:endParaRPr>
                     </a:p>
                   </a:txBody>
-                  <a:tcPr marL="14630400" marR="14630400" marT="0" marB="0" anchor="ctr">
+                  <a:tcPr marL="201168" marR="201168" marT="54864" marB="54864" anchor="ctr">
                     <a:lnL w="0" cap="flat" cmpd="sng" algn="ctr">
                       <a:noFill/>
                     </a:lnL>
@@ -15464,7 +15464,7 @@
                       </a:endParaRPr>
                     </a:p>
                   </a:txBody>
-                  <a:tcPr marL="14630400" marR="14630400" marT="0" marB="0" anchor="ctr">
+                  <a:tcPr marL="201168" marR="201168" marT="54864" marB="54864" anchor="ctr">
                     <a:lnL w="0" cap="flat" cmpd="sng" algn="ctr">
                       <a:noFill/>
                     </a:lnL>
@@ -15516,7 +15516,7 @@
                       </a:endParaRPr>
                     </a:p>
                   </a:txBody>
-                  <a:tcPr marL="14630400" marR="14630400" marT="0" marB="0" anchor="ctr">
+                  <a:tcPr marL="201168" marR="201168" marT="54864" marB="54864" anchor="ctr">
                     <a:lnL w="0" cap="flat" cmpd="sng" algn="ctr">
                       <a:noFill/>
                     </a:lnL>
@@ -15560,7 +15560,7 @@
                       </a:endParaRPr>
                     </a:p>
                   </a:txBody>
-                  <a:tcPr marL="14630400" marR="14630400" marT="0" marB="0" anchor="ctr">
+                  <a:tcPr marL="201168" marR="201168" marT="54864" marB="54864" anchor="ctr">
                     <a:lnL w="0" cap="flat" cmpd="sng" algn="ctr">
                       <a:noFill/>
                     </a:lnL>
@@ -15604,7 +15604,7 @@
                       </a:endParaRPr>
                     </a:p>
                   </a:txBody>
-                  <a:tcPr marL="14630400" marR="14630400" marT="0" marB="0" anchor="ctr">
+                  <a:tcPr marL="201168" marR="201168" marT="54864" marB="54864" anchor="ctr">
                     <a:lnL w="0" cap="flat" cmpd="sng" algn="ctr">
                       <a:noFill/>
                     </a:lnL>

</xml_diff>